<commit_message>
feat(pitch): unificar pitch deck modular en 4 capítulos con navegación y eliminar equipo fundador
</commit_message>
<xml_diff>
--- a/AgroTech_Brochure_Ejecutivo.pptx
+++ b/AgroTech_Brochure_Ejecutivo.pptx
@@ -7598,7 +7598,7 @@
               </a:defRPr>
             </a:pPr>
             <a:r>
-              <a:t>08 / GOBERNANZA &amp; EQUIPO</a:t>
+              <a:t>08 / GOBERNANZA &amp; ESCALABILIDAD</a:t>
             </a:r>
           </a:p>
         </p:txBody>
@@ -7633,7 +7633,7 @@
               </a:defRPr>
             </a:pPr>
             <a:r>
-              <a:t>Estructura Organizacional: Modelo Dual SpA + Cooperativa</a:t>
+              <a:t>Gobernanza Territorial: Modelo Dual SpA + Cooperativa &amp; Slicing Pie</a:t>
             </a:r>
           </a:p>
         </p:txBody>
@@ -7647,7 +7647,7 @@
         <p:spPr>
           <a:xfrm>
             <a:off x="731520" y="1463040"/>
-            <a:ext cx="2514600" cy="2926080"/>
+            <a:ext cx="3383280" cy="3108960"/>
           </a:xfrm>
           <a:prstGeom prst="roundRect">
             <a:avLst/>
@@ -7690,7 +7690,7 @@
         <p:spPr>
           <a:xfrm>
             <a:off x="868680" y="1600200"/>
-            <a:ext cx="2240280" cy="2651760"/>
+            <a:ext cx="3108960" cy="2834640"/>
           </a:xfrm>
           <a:prstGeom prst="rect">
             <a:avLst/>
@@ -7714,13 +7714,13 @@
               </a:defRPr>
             </a:pPr>
             <a:r>
-              <a:t>Daniel Santander</a:t>
+              <a:t>🏛️ AgroTech SpA</a:t>
             </a:r>
           </a:p>
           <a:p>
             <a:pPr>
               <a:spcAft>
-                <a:spcPts val="800"/>
+                <a:spcPts val="1000"/>
               </a:spcAft>
               <a:defRPr sz="1000" b="1">
                 <a:solidFill>
@@ -7729,11 +7729,14 @@
               </a:defRPr>
             </a:pPr>
             <a:r>
-              <a:t>Fundador &amp; Dirección General</a:t>
-            </a:r>
-          </a:p>
-          <a:p>
-            <a:pPr>
+              <a:t>Vehículo de Capital e IP</a:t>
+            </a:r>
+          </a:p>
+          <a:p>
+            <a:pPr>
+              <a:spcAft>
+                <a:spcPts val="400"/>
+              </a:spcAft>
               <a:defRPr sz="950">
                 <a:solidFill>
                   <a:srgbClr val="A7B9AF"/>
@@ -7741,7 +7744,37 @@
               </a:defRPr>
             </a:pPr>
             <a:r>
-              <a:t>Arquitecto de AgriTwin, autor intelectual del código, estrategia de producto y alianzas ESG internacionales.</a:t>
+              <a:t>• Sociedad por acciones custodia del código fuente y modelos biofísicos.</a:t>
+            </a:r>
+          </a:p>
+          <a:p>
+            <a:pPr>
+              <a:spcAft>
+                <a:spcPts val="400"/>
+              </a:spcAft>
+              <a:defRPr sz="950">
+                <a:solidFill>
+                  <a:srgbClr val="A7B9AF"/>
+                </a:solidFill>
+              </a:defRPr>
+            </a:pPr>
+            <a:r>
+              <a:t>• Titularidad de marcas, patentes y licencias internacionales.</a:t>
+            </a:r>
+          </a:p>
+          <a:p>
+            <a:pPr>
+              <a:spcAft>
+                <a:spcPts val="400"/>
+              </a:spcAft>
+              <a:defRPr sz="950">
+                <a:solidFill>
+                  <a:srgbClr val="A7B9AF"/>
+                </a:solidFill>
+              </a:defRPr>
+            </a:pPr>
+            <a:r>
+              <a:t>• Vehículo limpio para captación de capital privado y fondos de innovación.</a:t>
             </a:r>
           </a:p>
         </p:txBody>
@@ -7754,8 +7787,8 @@
         </p:nvSpPr>
         <p:spPr>
           <a:xfrm>
-            <a:off x="3429000" y="1463040"/>
-            <a:ext cx="2514600" cy="2926080"/>
+            <a:off x="4343400" y="1463040"/>
+            <a:ext cx="3383280" cy="3108960"/>
           </a:xfrm>
           <a:prstGeom prst="roundRect">
             <a:avLst/>
@@ -7797,8 +7830,8 @@
         </p:nvSpPr>
         <p:spPr>
           <a:xfrm>
-            <a:off x="3566160" y="1600200"/>
-            <a:ext cx="2240280" cy="2651760"/>
+            <a:off x="4480560" y="1600200"/>
+            <a:ext cx="3108960" cy="2834640"/>
           </a:xfrm>
           <a:prstGeom prst="rect">
             <a:avLst/>
@@ -7822,13 +7855,13 @@
               </a:defRPr>
             </a:pPr>
             <a:r>
-              <a:t>Paulina Urrutia</a:t>
+              <a:t>🚜 Cooperativa Territorial</a:t>
             </a:r>
           </a:p>
           <a:p>
             <a:pPr>
               <a:spcAft>
-                <a:spcPts val="800"/>
+                <a:spcPts val="1000"/>
               </a:spcAft>
               <a:defRPr sz="1000" b="1">
                 <a:solidFill>
@@ -7837,11 +7870,14 @@
               </a:defRPr>
             </a:pPr>
             <a:r>
-              <a:t>Dirección Técnica &amp; Hardware</a:t>
-            </a:r>
-          </a:p>
-          <a:p>
-            <a:pPr>
+              <a:t>Brazo Operativo de Campo</a:t>
+            </a:r>
+          </a:p>
+          <a:p>
+            <a:pPr>
+              <a:spcAft>
+                <a:spcPts val="400"/>
+              </a:spcAft>
               <a:defRPr sz="950">
                 <a:solidFill>
                   <a:srgbClr val="A7B9AF"/>
@@ -7849,7 +7885,37 @@
               </a:defRPr>
             </a:pPr>
             <a:r>
-              <a:t>Dirección de taller de manufactura en Talca, diseño PCB KiCad, gabinetes IP65 y validación de campo.</a:t>
+              <a:t>• Ensamblaje local de hardware KioT y mantención en predio.</a:t>
+            </a:r>
+          </a:p>
+          <a:p>
+            <a:pPr>
+              <a:spcAft>
+                <a:spcPts val="400"/>
+              </a:spcAft>
+              <a:defRPr sz="950">
+                <a:solidFill>
+                  <a:srgbClr val="A7B9AF"/>
+                </a:solidFill>
+              </a:defRPr>
+            </a:pPr>
+            <a:r>
+              <a:t>• Soporte técnico in situ en menos de 2 horas en la cuenca del Maule.</a:t>
+            </a:r>
+          </a:p>
+          <a:p>
+            <a:pPr>
+              <a:spcAft>
+                <a:spcPts val="400"/>
+              </a:spcAft>
+              <a:defRPr sz="950">
+                <a:solidFill>
+                  <a:srgbClr val="A7B9AF"/>
+                </a:solidFill>
+              </a:defRPr>
+            </a:pPr>
+            <a:r>
+              <a:t>• Distribución equitativa de excedentes operacionales entre técnicos locales.</a:t>
             </a:r>
           </a:p>
         </p:txBody>
@@ -7862,8 +7928,8 @@
         </p:nvSpPr>
         <p:spPr>
           <a:xfrm>
-            <a:off x="6126480" y="1463040"/>
-            <a:ext cx="2514600" cy="2926080"/>
+            <a:off x="7955280" y="1463040"/>
+            <a:ext cx="3383280" cy="3108960"/>
           </a:xfrm>
           <a:prstGeom prst="roundRect">
             <a:avLst/>
@@ -7905,8 +7971,8 @@
         </p:nvSpPr>
         <p:spPr>
           <a:xfrm>
-            <a:off x="6263640" y="1600200"/>
-            <a:ext cx="2240280" cy="2651760"/>
+            <a:off x="8092440" y="1600200"/>
+            <a:ext cx="3108960" cy="2834640"/>
           </a:xfrm>
           <a:prstGeom prst="rect">
             <a:avLst/>
@@ -7930,13 +7996,13 @@
               </a:defRPr>
             </a:pPr>
             <a:r>
-              <a:t>Wladimir</a:t>
+              <a:t>🥧 Modelo Slicing Pie</a:t>
             </a:r>
           </a:p>
           <a:p>
             <a:pPr>
               <a:spcAft>
-                <a:spcPts val="800"/>
+                <a:spcPts val="1000"/>
               </a:spcAft>
               <a:defRPr sz="1000" b="1">
                 <a:solidFill>
@@ -7945,11 +8011,14 @@
               </a:defRPr>
             </a:pPr>
             <a:r>
-              <a:t>Dirección Financiera &amp; Comunitaria</a:t>
-            </a:r>
-          </a:p>
-          <a:p>
-            <a:pPr>
+              <a:t>Justicia Distributiva y Escala</a:t>
+            </a:r>
+          </a:p>
+          <a:p>
+            <a:pPr>
+              <a:spcAft>
+                <a:spcPts val="400"/>
+              </a:spcAft>
               <a:defRPr sz="950">
                 <a:solidFill>
                   <a:srgbClr val="A7B9AF"/>
@@ -7957,7 +8026,37 @@
               </a:defRPr>
             </a:pPr>
             <a:r>
-              <a:t>Modelación financiera, convenios con APRs, gestión del Pasaporte Verde y vinculación campesina.</a:t>
+              <a:t>• Reparto dinámico según horas técnicas, riesgo y aportes reales de valor.</a:t>
+            </a:r>
+          </a:p>
+          <a:p>
+            <a:pPr>
+              <a:spcAft>
+                <a:spcPts val="400"/>
+              </a:spcAft>
+              <a:defRPr sz="950">
+                <a:solidFill>
+                  <a:srgbClr val="A7B9AF"/>
+                </a:solidFill>
+              </a:defRPr>
+            </a:pPr>
+            <a:r>
+              <a:t>• Blindaje de IP exclusivo en la SpA que previene disputas societarias.</a:t>
+            </a:r>
+          </a:p>
+          <a:p>
+            <a:pPr>
+              <a:spcAft>
+                <a:spcPts val="400"/>
+              </a:spcAft>
+              <a:defRPr sz="950">
+                <a:solidFill>
+                  <a:srgbClr val="A7B9AF"/>
+                </a:solidFill>
+              </a:defRPr>
+            </a:pPr>
+            <a:r>
+              <a:t>• Red de micro-agencias con técnicos agrícolas locales certificados.</a:t>
             </a:r>
           </a:p>
         </p:txBody>
@@ -7970,116 +8069,8 @@
         </p:nvSpPr>
         <p:spPr>
           <a:xfrm>
-            <a:off x="8823960" y="1463040"/>
-            <a:ext cx="2514600" cy="2926080"/>
-          </a:xfrm>
-          <a:prstGeom prst="roundRect">
-            <a:avLst/>
-          </a:prstGeom>
-          <a:solidFill>
-            <a:srgbClr val="132B20"/>
-          </a:solidFill>
-          <a:ln>
-            <a:noFill/>
-          </a:ln>
-        </p:spPr>
-        <p:style>
-          <a:lnRef idx="1">
-            <a:schemeClr val="accent1"/>
-          </a:lnRef>
-          <a:fillRef idx="3">
-            <a:schemeClr val="accent1"/>
-          </a:fillRef>
-          <a:effectRef idx="2">
-            <a:schemeClr val="accent1"/>
-          </a:effectRef>
-          <a:fontRef idx="minor">
-            <a:schemeClr val="lt1"/>
-          </a:fontRef>
-        </p:style>
-        <p:txBody>
-          <a:bodyPr rtlCol="0" anchor="ctr"/>
-          <a:lstStyle/>
-          <a:p>
-            <a:pPr algn="ctr"/>
-          </a:p>
-        </p:txBody>
-      </p:sp>
-      <p:sp>
-        <p:nvSpPr>
-          <p:cNvPr id="12" name="TextBox 11"/>
-          <p:cNvSpPr txBox="1"/>
-          <p:nvPr/>
-        </p:nvSpPr>
-        <p:spPr>
-          <a:xfrm>
-            <a:off x="8961120" y="1600200"/>
-            <a:ext cx="2240280" cy="2651760"/>
-          </a:xfrm>
-          <a:prstGeom prst="rect">
-            <a:avLst/>
-          </a:prstGeom>
-          <a:noFill/>
-        </p:spPr>
-        <p:txBody>
-          <a:bodyPr wrap="square">
-            <a:spAutoFit/>
-          </a:bodyPr>
-          <a:lstStyle/>
-          <a:p>
-            <a:pPr>
-              <a:spcAft>
-                <a:spcPts val="200"/>
-              </a:spcAft>
-              <a:defRPr sz="1400" b="1">
-                <a:solidFill>
-                  <a:srgbClr val="FFFFFF"/>
-                </a:solidFill>
-              </a:defRPr>
-            </a:pPr>
-            <a:r>
-              <a:t>Pablo</a:t>
-            </a:r>
-          </a:p>
-          <a:p>
-            <a:pPr>
-              <a:spcAft>
-                <a:spcPts val="800"/>
-              </a:spcAft>
-              <a:defRPr sz="1000" b="1">
-                <a:solidFill>
-                  <a:srgbClr val="10B981"/>
-                </a:solidFill>
-              </a:defRPr>
-            </a:pPr>
-            <a:r>
-              <a:t>Inteligencia Comercial &amp; Software</a:t>
-            </a:r>
-          </a:p>
-          <a:p>
-            <a:pPr>
-              <a:defRPr sz="950">
-                <a:solidFill>
-                  <a:srgbClr val="A7B9AF"/>
-                </a:solidFill>
-              </a:defRPr>
-            </a:pPr>
-            <a:r>
-              <a:t>Modelación de algoritmos de optimización, CRM comercial, calculadoras de ROI y soporte técnico.</a:t>
-            </a:r>
-          </a:p>
-        </p:txBody>
-      </p:sp>
-      <p:sp>
-        <p:nvSpPr>
-          <p:cNvPr id="13" name="Rounded Rectangle 12"/>
-          <p:cNvSpPr/>
-          <p:nvPr/>
-        </p:nvSpPr>
-        <p:spPr>
-          <a:xfrm>
-            <a:off x="731520" y="4663440"/>
-            <a:ext cx="10728655" cy="1737360"/>
+            <a:off x="731520" y="4754880"/>
+            <a:ext cx="10728655" cy="1645920"/>
           </a:xfrm>
           <a:prstGeom prst="roundRect">
             <a:avLst/>
@@ -8117,14 +8108,14 @@
       </p:sp>
       <p:sp>
         <p:nvSpPr>
-          <p:cNvPr id="14" name="TextBox 13"/>
+          <p:cNvPr id="12" name="TextBox 11"/>
           <p:cNvSpPr txBox="1"/>
           <p:nvPr/>
         </p:nvSpPr>
         <p:spPr>
           <a:xfrm>
-            <a:off x="914400" y="4754880"/>
-            <a:ext cx="10332720" cy="1554480"/>
+            <a:off x="914400" y="4846320"/>
+            <a:ext cx="10332720" cy="1463040"/>
           </a:xfrm>
           <a:prstGeom prst="rect">
             <a:avLst/>
@@ -8148,7 +8139,7 @@
               </a:defRPr>
             </a:pPr>
             <a:r>
-              <a:t>🏛️ MODELO DE GOBERNANZA DUAL Y RED COOPERATIVA ASOCIADA</a:t>
+              <a:t>🛡️ BLINDAJE ESTRATÉGICO Y ALINEACIÓN DE INCENTIVOS TERRITORIALES</a:t>
             </a:r>
           </a:p>
           <a:p>
@@ -8160,15 +8151,15 @@
               </a:defRPr>
             </a:pPr>
             <a:r>
-              <a:t>• AgroTech SpA: Holding propietaria de los activos tecnológicos, licenciamiento de software y captación de capital de riesgo.</a:t>
+              <a:t>• Separación Estricta: La IP y el software escalable nunca se fragmentan, residen 100% en la SpA.</a:t>
             </a:r>
             <a:br/>
             <a:r>
-              <a:t>• Cooperativa de Trabajo AgroTech: Brazo ejecutor donde participan los profesionales de terreno (Luis González en drones multiespectrales, Dra. Camila Morales en microbiología de suelos, Matías Riquelme en derecho cooperativo e Ignacia Valenzuela en vínculo campesino).</a:t>
+              <a:t>• Cero Rotación de Terreno: Los instaladores y técnicos locales son cooperados de la entidad operativa, compartiendo beneficios de instalación y fidelizando a las familias agrícolas.</a:t>
             </a:r>
             <a:br/>
             <a:r>
-              <a:t>• Propiedad Intelectual blindada: Licencia exclusiva de explotación a favor de la SpA con cláusula de reversión bioética.</a:t>
+              <a:t>• Escalabilidad Nacional: El modelo se replica por cuencas asociando cooperativas y micro-agencias locales homologadas bajo estándar AgroTech.</a:t>
             </a:r>
           </a:p>
         </p:txBody>

</xml_diff>

<commit_message>
feat(pitch): expandir pitch maestro a 23 slides con precios USD, árbol alquímico, flywheel y talento buscado
</commit_message>
<xml_diff>
--- a/AgroTech_Brochure_Ejecutivo.pptx
+++ b/AgroTech_Brochure_Ejecutivo.pptx
@@ -6512,7 +6512,7 @@
               </a:defRPr>
             </a:pPr>
             <a:r>
-              <a:t>BÁSICO (PREDIAL)</a:t>
+              <a:t>PLAN BÁSICO (PREDIAL)</a:t>
             </a:r>
           </a:p>
           <a:p>
@@ -6527,7 +6527,7 @@
               </a:defRPr>
             </a:pPr>
             <a:r>
-              <a:t>$45.000 CLP/mes</a:t>
+              <a:t>$50 USD/mes</a:t>
             </a:r>
           </a:p>
           <a:p>
@@ -6556,7 +6556,7 @@
             </a:r>
             <a:br/>
             <a:r>
-              <a:t>• Setup digital: $120.000</a:t>
+              <a:t>• Setup digital: $120 USD</a:t>
             </a:r>
           </a:p>
         </p:txBody>
@@ -6639,7 +6639,7 @@
               </a:defRPr>
             </a:pPr>
             <a:r>
-              <a:t>PRO (FRUTÍCOLA / VIÑA)</a:t>
+              <a:t>PLAN PRO (FRUTÍCOLA / VIÑA)</a:t>
             </a:r>
           </a:p>
           <a:p>
@@ -6654,7 +6654,7 @@
               </a:defRPr>
             </a:pPr>
             <a:r>
-              <a:t>$85.000 CLP/mes</a:t>
+              <a:t>$92 USD/mes</a:t>
             </a:r>
           </a:p>
           <a:p>
@@ -6764,7 +6764,7 @@
               </a:defRPr>
             </a:pPr>
             <a:r>
-              <a:t>ENTERPRISE / EXPORTADOR</a:t>
+              <a:t>PLAN EMPRESA (EXPORTADOR)</a:t>
             </a:r>
           </a:p>
           <a:p>
@@ -6779,7 +6779,7 @@
               </a:defRPr>
             </a:pPr>
             <a:r>
-              <a:t>$160.000 CLP/mes</a:t>
+              <a:t>$170 USD/mes</a:t>
             </a:r>
           </a:p>
           <a:p>
@@ -6889,7 +6889,7 @@
               </a:defRPr>
             </a:pPr>
             <a:r>
-              <a:t>HARDWARE KIOT</a:t>
+              <a:t>KITS A.P.I.S. / KIOT</a:t>
             </a:r>
           </a:p>
           <a:p>
@@ -6904,7 +6904,7 @@
               </a:defRPr>
             </a:pPr>
             <a:r>
-              <a:t>$185k - $380k CLP</a:t>
+              <a:t>$90 - $300 USD</a:t>
             </a:r>
           </a:p>
           <a:p>
@@ -6916,20 +6916,20 @@
               </a:defRPr>
             </a:pPr>
             <a:r>
-              <a:t>Venta directa o HaaS</a:t>
+              <a:t>Manufactura en Talca</a:t>
             </a:r>
             <a:br/>
             <a:br/>
             <a:r>
-              <a:t>• Kit Riego: $185.000 (58% margen)</a:t>
+              <a:t>• Costo BOM: ~$90 USD ($85k CLP)</a:t>
             </a:r>
             <a:br/>
             <a:r>
-              <a:t>• Kit Heladas: $220.000</a:t>
+              <a:t>• Venta nodo: ~$300 USD ($280k CLP)</a:t>
             </a:r>
             <a:br/>
             <a:r>
-              <a:t>• Modelo HaaS: $28.000/mes</a:t>
+              <a:t>• Margen bruto de hardware: 70%</a:t>
             </a:r>
             <a:br/>
             <a:r>

</xml_diff>